<commit_message>
Update HIDRO site content
Co-authored-by: Copilot App <223556219+Copilot@users.noreply.github.com>
</commit_message>
<xml_diff>
--- a/materiais/HIDRO_Oficina_Agentes_Pesquisadores_Seminario_RRD.pptx
+++ b/materiais/HIDRO_Oficina_Agentes_Pesquisadores_Seminario_RRD.pptx
@@ -25410,7 +25410,7 @@
                 <a:ea typeface="Calibri" pitchFamily="34" charset="-122"/>
                 <a:cs typeface="Calibri" pitchFamily="34" charset="-120"/>
               </a:rPr>
-              <a:t>O que são alagamento, enxurrada, enchente e deslizamento; por que acontecem.</a:t>
+              <a:t>O que são alagamento, enxurrada, enchente, inundação (não são sinônimos) e deslizamento.</a:t>
             </a:r>
             <a:endParaRPr lang="en-US" sz="1500" dirty="0"/>
           </a:p>
@@ -26166,7 +26166,7 @@
                 <a:ea typeface="Calibri" pitchFamily="34" charset="-122"/>
                 <a:cs typeface="Calibri" pitchFamily="34" charset="-120"/>
               </a:rPr>
-              <a:t>Alagamento, enxurrada, enchente e deslizamento.</a:t>
+              <a:t>Alagamento, enxurrada, enchente/inundação e deslizamento.</a:t>
             </a:r>
             <a:endParaRPr lang="en-US" sz="1500" dirty="0"/>
           </a:p>

</xml_diff>

<commit_message>
Adiciona novas funcionalidades e prepara para mais imagens6
</commit_message>
<xml_diff>
--- a/materiais/HIDRO_Oficina_Agentes_Pesquisadores_Seminario_RRD.pptx
+++ b/materiais/HIDRO_Oficina_Agentes_Pesquisadores_Seminario_RRD.pptx
@@ -20828,6 +20828,10 @@
             </a:outerShdw>
           </a:effectLst>
         </p:spPr>
+        <p:txBody>
+          <a:bodyPr/>
+          <a:p/>
+        </p:txBody>
       </p:sp>
       <p:sp>
         <p:nvSpPr>
@@ -20853,6 +20857,10 @@
             <a:prstDash val="solid"/>
           </a:ln>
         </p:spPr>
+        <p:txBody>
+          <a:bodyPr/>
+          <a:p/>
+        </p:txBody>
       </p:sp>
       <p:pic>
         <p:nvPicPr>
@@ -20950,6 +20958,10 @@
             </a:outerShdw>
           </a:effectLst>
         </p:spPr>
+        <p:txBody>
+          <a:bodyPr/>
+          <a:p/>
+        </p:txBody>
       </p:sp>
       <p:sp>
         <p:nvSpPr>
@@ -20975,6 +20987,10 @@
             <a:prstDash val="solid"/>
           </a:ln>
         </p:spPr>
+        <p:txBody>
+          <a:bodyPr/>
+          <a:p/>
+        </p:txBody>
       </p:sp>
       <p:pic>
         <p:nvPicPr>
@@ -21072,6 +21088,10 @@
             </a:outerShdw>
           </a:effectLst>
         </p:spPr>
+        <p:txBody>
+          <a:bodyPr/>
+          <a:p/>
+        </p:txBody>
       </p:sp>
       <p:sp>
         <p:nvSpPr>
@@ -21097,6 +21117,10 @@
             <a:prstDash val="solid"/>
           </a:ln>
         </p:spPr>
+        <p:txBody>
+          <a:bodyPr/>
+          <a:p/>
+        </p:txBody>
       </p:sp>
       <p:pic>
         <p:nvPicPr>
@@ -21194,6 +21218,10 @@
             </a:outerShdw>
           </a:effectLst>
         </p:spPr>
+        <p:txBody>
+          <a:bodyPr/>
+          <a:p/>
+        </p:txBody>
       </p:sp>
       <p:sp>
         <p:nvSpPr>
@@ -21219,6 +21247,10 @@
             <a:prstDash val="solid"/>
           </a:ln>
         </p:spPr>
+        <p:txBody>
+          <a:bodyPr/>
+          <a:p/>
+        </p:txBody>
       </p:sp>
       <p:pic>
         <p:nvPicPr>
@@ -21316,6 +21348,10 @@
             </a:outerShdw>
           </a:effectLst>
         </p:spPr>
+        <p:txBody>
+          <a:bodyPr/>
+          <a:p/>
+        </p:txBody>
       </p:sp>
       <p:sp>
         <p:nvSpPr>
@@ -21341,6 +21377,10 @@
             <a:prstDash val="solid"/>
           </a:ln>
         </p:spPr>
+        <p:txBody>
+          <a:bodyPr/>
+          <a:p/>
+        </p:txBody>
       </p:sp>
       <p:pic>
         <p:nvPicPr>
@@ -21402,6 +21442,17 @@
               <a:t>A efetividade do jogo ainda está em avaliação. Licenciamento em definição.</a:t>
             </a:r>
             <a:endParaRPr lang="en-US" sz="1600" dirty="0"/>
+          </a:p>
+          <a:p>
+            <a:r>
+              <a:rPr sz="1600">
+                <a:solidFill>
+                  <a:srgbClr val="FFFFFF"/>
+                </a:solidFill>
+                <a:latin typeface="Calibri"/>
+              </a:rPr>
+              <a:t>Programa de computador registrado no INPI sob o processo nº BR 51 2026 009207-8, titularidade da UFGD.</a:t>
+            </a:r>
           </a:p>
         </p:txBody>
       </p:sp>
@@ -26461,7 +26512,7 @@
               <a:buNone/>
             </a:pPr>
             <a:r>
-              <a:rPr lang="en-US" sz="1200" b="1" dirty="0">
+              <a:rPr lang="en-US" sz="1100" b="1" dirty="0">
                 <a:solidFill>
                   <a:srgbClr val="D9A21B"/>
                 </a:solidFill>
@@ -26471,7 +26522,7 @@
               </a:rPr>
               <a:t>ALAGAMENTO</a:t>
             </a:r>
-            <a:endParaRPr lang="en-US" sz="1200" dirty="0"/>
+            <a:endParaRPr lang="en-US" sz="1100" dirty="0"/>
           </a:p>
         </p:txBody>
       </p:sp>
@@ -26558,7 +26609,7 @@
               <a:buNone/>
             </a:pPr>
             <a:r>
-              <a:rPr lang="en-US" sz="1200" b="1" dirty="0">
+              <a:rPr lang="en-US" sz="1100" b="1" dirty="0">
                 <a:solidFill>
                   <a:srgbClr val="E57A2E"/>
                 </a:solidFill>
@@ -26568,7 +26619,7 @@
               </a:rPr>
               <a:t>ENXURRADA</a:t>
             </a:r>
-            <a:endParaRPr lang="en-US" sz="1200" dirty="0"/>
+            <a:endParaRPr lang="en-US" sz="1100" dirty="0"/>
           </a:p>
         </p:txBody>
       </p:sp>
@@ -26655,7 +26706,7 @@
               <a:buNone/>
             </a:pPr>
             <a:r>
-              <a:rPr lang="en-US" sz="1200" b="1" dirty="0">
+              <a:rPr lang="en-US" sz="1100" b="1" dirty="0">
                 <a:solidFill>
                   <a:srgbClr val="2FA36B"/>
                 </a:solidFill>
@@ -26663,9 +26714,9 @@
                 <a:ea typeface="Calibri" pitchFamily="34" charset="-122"/>
                 <a:cs typeface="Calibri" pitchFamily="34" charset="-120"/>
               </a:rPr>
-              <a:t>ENCHENTE</a:t>
-            </a:r>
-            <a:endParaRPr lang="en-US" sz="1200" dirty="0"/>
+              <a:t>ENCHENTE E INUNDAÇÃO</a:t>
+            </a:r>
+            <a:endParaRPr lang="en-US" sz="1100" dirty="0"/>
           </a:p>
         </p:txBody>
       </p:sp>
@@ -26752,7 +26803,7 @@
               <a:buNone/>
             </a:pPr>
             <a:r>
-              <a:rPr lang="en-US" sz="1200" b="1" dirty="0">
+              <a:rPr lang="en-US" sz="1100" b="1" dirty="0">
                 <a:solidFill>
                   <a:srgbClr val="D64545"/>
                 </a:solidFill>
@@ -26762,7 +26813,7 @@
               </a:rPr>
               <a:t>DESLIZAMENTO</a:t>
             </a:r>
-            <a:endParaRPr lang="en-US" sz="1200" dirty="0"/>
+            <a:endParaRPr lang="en-US" sz="1100" dirty="0"/>
           </a:p>
         </p:txBody>
       </p:sp>

</xml_diff>